<commit_message>
Fixed ppt for PolyMix_Comparison_Presentation
</commit_message>
<xml_diff>
--- a/experiments_polypmix/results/PolyMix_Comparison_Presentation.pptx
+++ b/experiments_polypmix/results/PolyMix_Comparison_Presentation.pptx
@@ -5172,7 +5172,7 @@
         <p:spPr>
           <a:xfrm>
             <a:off x="457200" y="1097280"/>
-            <a:ext cx="8229600" cy="5029200"/>
+            <a:ext cx="8229600" cy="5970865"/>
           </a:xfrm>
           <a:prstGeom prst="rect">
             <a:avLst/>
@@ -5192,7 +5192,8 @@
               <a:defRPr sz="1800"/>
             </a:pPr>
             <a:r>
-              <a:t>📊 Overall Performance:</a:t>
+              <a:rPr dirty="0"/>
+              <a:t> Overall Performance:</a:t>
             </a:r>
           </a:p>
           <a:p>
@@ -5203,6 +5204,7 @@
               <a:defRPr sz="1800"/>
             </a:pPr>
             <a:r>
+              <a:rPr dirty="0"/>
               <a:t>   • Ratio 2.0 wins in 3/5 training sizes (50, 75, 490)</a:t>
             </a:r>
           </a:p>
@@ -5214,6 +5216,7 @@
               <a:defRPr sz="1800"/>
             </a:pPr>
             <a:r>
+              <a:rPr dirty="0"/>
               <a:t>   • Ratio 1.0 wins in 2/5 training sizes (25, 100)</a:t>
             </a:r>
           </a:p>
@@ -5224,7 +5227,7 @@
               </a:spcAft>
               <a:defRPr sz="1800"/>
             </a:pPr>
-            <a:endParaRPr/>
+            <a:endParaRPr dirty="0"/>
           </a:p>
           <a:p>
             <a:pPr>
@@ -5234,7 +5237,8 @@
               <a:defRPr sz="1800" b="1"/>
             </a:pPr>
             <a:r>
-              <a:t>🎯 Best Results Achieved:</a:t>
+              <a:rPr dirty="0"/>
+              <a:t>Best Results Achieved:</a:t>
             </a:r>
           </a:p>
           <a:p>
@@ -5245,6 +5249,7 @@
               <a:defRPr sz="1800"/>
             </a:pPr>
             <a:r>
+              <a:rPr dirty="0"/>
               <a:t>   • Highest Dice Score: 0.9443 (Ratio 2.0, TS=490)</a:t>
             </a:r>
           </a:p>
@@ -5256,6 +5261,7 @@
               <a:defRPr sz="1800"/>
             </a:pPr>
             <a:r>
+              <a:rPr dirty="0"/>
               <a:t>   • Both ratios achieve &gt;94% Dice with full dataset</a:t>
             </a:r>
           </a:p>
@@ -5266,7 +5272,7 @@
               </a:spcAft>
               <a:defRPr sz="1800"/>
             </a:pPr>
-            <a:endParaRPr/>
+            <a:endParaRPr dirty="0"/>
           </a:p>
           <a:p>
             <a:pPr>
@@ -5276,7 +5282,8 @@
               <a:defRPr sz="1800"/>
             </a:pPr>
             <a:r>
-              <a:t>⚡ Convergence Patterns:</a:t>
+              <a:rPr dirty="0"/>
+              <a:t> Convergence Patterns:</a:t>
             </a:r>
           </a:p>
           <a:p>
@@ -5287,6 +5294,7 @@
               <a:defRPr sz="1800"/>
             </a:pPr>
             <a:r>
+              <a:rPr dirty="0"/>
               <a:t>   • Smaller datasets (25, 50) require more epochs</a:t>
             </a:r>
           </a:p>
@@ -5298,6 +5306,7 @@
               <a:defRPr sz="1800"/>
             </a:pPr>
             <a:r>
+              <a:rPr dirty="0"/>
               <a:t>   • Larger datasets converge faster (within 15-25 epochs)</a:t>
             </a:r>
           </a:p>
@@ -5308,7 +5317,10 @@
               </a:spcAft>
               <a:defRPr sz="1800"/>
             </a:pPr>
-            <a:endParaRPr/>
+            <a:r>
+              <a:rPr dirty="0"/>
+              <a:t> Recommendations:</a:t>
+            </a:r>
           </a:p>
           <a:p>
             <a:pPr>
@@ -5318,7 +5330,8 @@
               <a:defRPr sz="1800"/>
             </a:pPr>
             <a:r>
-              <a:t>💡 Recommendations:</a:t>
+              <a:rPr dirty="0"/>
+              <a:t>   • Use Ratio 2.0 for limited data scenarios (50-75 images)</a:t>
             </a:r>
           </a:p>
           <a:p>
@@ -5329,17 +5342,7 @@
               <a:defRPr sz="1800"/>
             </a:pPr>
             <a:r>
-              <a:t>   • Use Ratio 2.0 for limited data scenarios (50-75 images)</a:t>
-            </a:r>
-          </a:p>
-          <a:p>
-            <a:pPr>
-              <a:spcAft>
-                <a:spcPts val="1200"/>
-              </a:spcAft>
-              <a:defRPr sz="1800"/>
-            </a:pPr>
-            <a:r>
+              <a:rPr dirty="0"/>
               <a:t>   • Both ratios work similarly well with large datasets</a:t>
             </a:r>
           </a:p>
@@ -5414,7 +5417,7 @@
         <p:spPr>
           <a:xfrm>
             <a:off x="457200" y="1097280"/>
-            <a:ext cx="8229600" cy="5029200"/>
+            <a:ext cx="8229600" cy="5109091"/>
           </a:xfrm>
           <a:prstGeom prst="rect">
             <a:avLst/>
@@ -5434,7 +5437,8 @@
               <a:defRPr sz="1800"/>
             </a:pPr>
             <a:r>
-              <a:t>🔧 Experiment Configuration:</a:t>
+              <a:rPr dirty="0"/>
+              <a:t> Experiment Configuration:</a:t>
             </a:r>
           </a:p>
           <a:p>
@@ -5445,6 +5449,7 @@
               <a:defRPr sz="1800"/>
             </a:pPr>
             <a:r>
+              <a:rPr dirty="0"/>
               <a:t>   • Batch Size: 8</a:t>
             </a:r>
           </a:p>
@@ -5456,6 +5461,7 @@
               <a:defRPr sz="1800"/>
             </a:pPr>
             <a:r>
+              <a:rPr dirty="0"/>
               <a:t>   • Learning Rate: 0.0001</a:t>
             </a:r>
           </a:p>
@@ -5467,6 +5473,7 @@
               <a:defRPr sz="1800"/>
             </a:pPr>
             <a:r>
+              <a:rPr dirty="0"/>
               <a:t>   • Image Size: 224 × 224</a:t>
             </a:r>
           </a:p>
@@ -5478,6 +5485,7 @@
               <a:defRPr sz="1800"/>
             </a:pPr>
             <a:r>
+              <a:rPr dirty="0"/>
               <a:t>   • Early Stopping: 10 epochs patience</a:t>
             </a:r>
           </a:p>
@@ -5489,6 +5497,7 @@
               <a:defRPr sz="1800"/>
             </a:pPr>
             <a:r>
+              <a:rPr dirty="0"/>
               <a:t>   • Maximum Epochs: 50</a:t>
             </a:r>
           </a:p>
@@ -5499,7 +5508,7 @@
               </a:spcAft>
               <a:defRPr sz="1800"/>
             </a:pPr>
-            <a:endParaRPr/>
+            <a:endParaRPr dirty="0"/>
           </a:p>
           <a:p>
             <a:pPr>
@@ -5509,7 +5518,8 @@
               <a:defRPr sz="1800"/>
             </a:pPr>
             <a:r>
-              <a:t>📁 Training Sizes Tested:</a:t>
+              <a:rPr dirty="0"/>
+              <a:t> Training Sizes Tested:</a:t>
             </a:r>
           </a:p>
           <a:p>
@@ -5520,6 +5530,7 @@
               <a:defRPr sz="1800"/>
             </a:pPr>
             <a:r>
+              <a:rPr dirty="0"/>
               <a:t>   • 25, 50, 75, 100, 490 images</a:t>
             </a:r>
           </a:p>
@@ -5530,7 +5541,7 @@
               </a:spcAft>
               <a:defRPr sz="1800"/>
             </a:pPr>
-            <a:endParaRPr/>
+            <a:endParaRPr dirty="0"/>
           </a:p>
           <a:p>
             <a:pPr>
@@ -5540,7 +5551,8 @@
               <a:defRPr sz="1800"/>
             </a:pPr>
             <a:r>
-              <a:t>🎯 Model Selection Criterion:</a:t>
+              <a:rPr dirty="0"/>
+              <a:t> Model Selection Criterion:</a:t>
             </a:r>
           </a:p>
           <a:p>
@@ -5551,6 +5563,7 @@
               <a:defRPr sz="1800" b="1"/>
             </a:pPr>
             <a:r>
+              <a:rPr dirty="0"/>
               <a:t>   • Best Validation Dice Score</a:t>
             </a:r>
           </a:p>
@@ -5625,7 +5638,7 @@
         <p:spPr>
           <a:xfrm>
             <a:off x="457200" y="1097280"/>
-            <a:ext cx="8229600" cy="5029200"/>
+            <a:ext cx="8229600" cy="6832640"/>
           </a:xfrm>
           <a:prstGeom prst="rect">
             <a:avLst/>
@@ -5645,7 +5658,8 @@
               <a:defRPr sz="1800"/>
             </a:pPr>
             <a:r>
-              <a:t>✅ Conclusions:</a:t>
+              <a:rPr dirty="0"/>
+              <a:t> Conclusions:</a:t>
             </a:r>
           </a:p>
           <a:p>
@@ -5655,7 +5669,7 @@
               </a:spcAft>
               <a:defRPr sz="1800"/>
             </a:pPr>
-            <a:endParaRPr/>
+            <a:endParaRPr dirty="0"/>
           </a:p>
           <a:p>
             <a:pPr>
@@ -5665,6 +5679,7 @@
               <a:defRPr sz="1800"/>
             </a:pPr>
             <a:r>
+              <a:rPr dirty="0"/>
               <a:t>1. Both augmentation ratios achieve strong performance</a:t>
             </a:r>
           </a:p>
@@ -5676,6 +5691,7 @@
               <a:defRPr sz="1800"/>
             </a:pPr>
             <a:r>
+              <a:rPr dirty="0"/>
               <a:t>   with best Dice scores exceeding 94%</a:t>
             </a:r>
           </a:p>
@@ -5686,7 +5702,7 @@
               </a:spcAft>
               <a:defRPr sz="1800"/>
             </a:pPr>
-            <a:endParaRPr/>
+            <a:endParaRPr dirty="0"/>
           </a:p>
           <a:p>
             <a:pPr>
@@ -5696,6 +5712,7 @@
               <a:defRPr sz="1800"/>
             </a:pPr>
             <a:r>
+              <a:rPr dirty="0"/>
               <a:t>2. Ratio 2.0 shows slight advantage for medium-sized</a:t>
             </a:r>
           </a:p>
@@ -5707,6 +5724,7 @@
               <a:defRPr sz="1800"/>
             </a:pPr>
             <a:r>
+              <a:rPr dirty="0"/>
               <a:t>   datasets (50-75 images)</a:t>
             </a:r>
           </a:p>
@@ -5717,7 +5735,7 @@
               </a:spcAft>
               <a:defRPr sz="1800"/>
             </a:pPr>
-            <a:endParaRPr/>
+            <a:endParaRPr dirty="0"/>
           </a:p>
           <a:p>
             <a:pPr>
@@ -5727,6 +5745,7 @@
               <a:defRPr sz="1800"/>
             </a:pPr>
             <a:r>
+              <a:rPr dirty="0"/>
               <a:t>3. Ratio 1.0 performs better with very small (25) and</a:t>
             </a:r>
           </a:p>
@@ -5738,6 +5757,7 @@
               <a:defRPr sz="1800"/>
             </a:pPr>
             <a:r>
+              <a:rPr dirty="0"/>
               <a:t>   moderate (100) training sets</a:t>
             </a:r>
           </a:p>
@@ -5748,7 +5768,7 @@
               </a:spcAft>
               <a:defRPr sz="1800"/>
             </a:pPr>
-            <a:endParaRPr/>
+            <a:endParaRPr dirty="0"/>
           </a:p>
           <a:p>
             <a:pPr>
@@ -5758,6 +5778,7 @@
               <a:defRPr sz="1800"/>
             </a:pPr>
             <a:r>
+              <a:rPr dirty="0"/>
               <a:t>4. Training size has the most significant impact on</a:t>
             </a:r>
           </a:p>
@@ -5769,6 +5790,7 @@
               <a:defRPr sz="1800"/>
             </a:pPr>
             <a:r>
+              <a:rPr dirty="0"/>
               <a:t>   final model performance</a:t>
             </a:r>
           </a:p>
@@ -5779,7 +5801,7 @@
               </a:spcAft>
               <a:defRPr sz="1800"/>
             </a:pPr>
-            <a:endParaRPr/>
+            <a:endParaRPr dirty="0"/>
           </a:p>
           <a:p>
             <a:pPr>
@@ -5789,6 +5811,7 @@
               <a:defRPr sz="1800"/>
             </a:pPr>
             <a:r>
+              <a:rPr dirty="0"/>
               <a:t>5. Early stopping effectively prevents overfitting</a:t>
             </a:r>
           </a:p>
@@ -5800,6 +5823,7 @@
               <a:defRPr sz="1800"/>
             </a:pPr>
             <a:r>
+              <a:rPr dirty="0"/>
               <a:t>   in all configurations</a:t>
             </a:r>
           </a:p>

</xml_diff>